<commit_message>
Arrange CTF architecture horizontally and add Mixture input
</commit_message>
<xml_diff>
--- a/reports/20261016_ctf_model/ctf_estimation_model.pptx
+++ b/reports/20261016_ctf_model/ctf_estimation_model.pptx
@@ -503,6 +503,16 @@
           <a:p>
             <a:r>
               <a:t>User-requested abstract CTF estimator diagram. Time Module then Frequency Module is repeated N times on features [T,F,D]. Speaker-specific weighted pooling reduces T and produces two [F,D] representations. Each representation is processed separately by the post-pooling frequency module and CTF output mapping. Existing implementation applies the same post-pooling module weights independently to each speaker; the two drawn boxes show separate processing, not independently parameterized weights. Batch dimension, STFT/Conv2D encoder, slot embeddings, detailed CTF head and number of post-pooling layers are omitted for simplicity. Actual complex output per speaker is [F,L], with L CTF taps. No fixed N is asserted.</a:t>
+            </a:r>
+          </a:p>
+          <a:p>
+            <a:r>
+              <a:t>Horizontal revision: left-to-right Mixture -&gt; N repeated Time/Frequency stages -&gt; Pooling -&gt; speaker branches -&gt; Frequency Module -&gt; CTF. Mixture label denotes waveform input; STFT and Conv2D frontend remain abstracted. Visual inspiration: the block grouping in TF-Locoformer Fig. 1, https://www.merl.com/publications/docs/TR2024-126.pdf. All architecture shapes are original editable drawings, not a reproduced paper figure.</a:t>
+            </a:r>
+          </a:p>
+          <a:p>
+            <a:r>
+              <a:t>Horizontal revision: left-to-right Mixture -&gt; N repeated Time/Frequency stages -&gt; Pooling -&gt; speaker branches -&gt; Frequency Module -&gt; CTF. Mixture label denotes waveform input; STFT and Conv2D frontend remain abstracted. Visual inspiration: the block grouping in TF-Locoformer Fig. 1, https://www.merl.com/publications/docs/TR2024-126.pdf. All architecture shapes are original editable drawings, not a reproduced paper figure.</a:t>
             </a:r>
           </a:p>
         </p:txBody>
@@ -3533,7 +3543,7 @@
           <a:noFill/>
         </p:spPr>
         <p:txBody>
-          <a:bodyPr wrap="none" lIns="18288" rIns="18288" tIns="9144" bIns="9144">
+          <a:bodyPr wrap="none" lIns="9144" rIns="9144" tIns="9144" bIns="9144">
             <a:spAutoFit/>
           </a:bodyPr>
           <a:lstStyle/>
@@ -3563,12 +3573,12 @@
         </p:nvSpPr>
         <p:spPr>
           <a:xfrm>
-            <a:off x="676656" y="1746504"/>
-            <a:ext cx="3090672" cy="3246120"/>
+            <a:off x="1664208" y="2331720"/>
+            <a:ext cx="3767328" cy="2286000"/>
           </a:xfrm>
           <a:prstGeom prst="roundRect">
             <a:avLst>
-              <a:gd name="adj" fmla="val 7000"/>
+              <a:gd name="adj" fmla="val 6500"/>
             </a:avLst>
           </a:prstGeom>
           <a:noFill/>
@@ -3609,8 +3619,8 @@
         </p:nvSpPr>
         <p:spPr>
           <a:xfrm>
-            <a:off x="2880360" y="1883664"/>
-            <a:ext cx="731520" cy="429768"/>
+            <a:off x="4636008" y="2414016"/>
+            <a:ext cx="640080" cy="338328"/>
           </a:xfrm>
           <a:prstGeom prst="rect">
             <a:avLst/>
@@ -3618,12 +3628,51 @@
           <a:noFill/>
         </p:spPr>
         <p:txBody>
-          <a:bodyPr wrap="none" lIns="18288" rIns="18288" tIns="9144" bIns="9144">
+          <a:bodyPr wrap="none" lIns="9144" rIns="9144" tIns="9144" bIns="9144">
             <a:spAutoFit/>
           </a:bodyPr>
           <a:lstStyle/>
           <a:p>
-            <a:pPr algn="l">
+            <a:pPr algn="ctr">
+              <a:spcAft>
+                <a:spcPts val="100"/>
+              </a:spcAft>
+            </a:pPr>
+            <a:r>
+              <a:rPr sz="2100" b="1">
+                <a:solidFill>
+                  <a:srgbClr val="000000"/>
+                </a:solidFill>
+                <a:latin typeface="Arial"/>
+              </a:rPr>
+              <a:t>× N</a:t>
+            </a:r>
+          </a:p>
+        </p:txBody>
+      </p:sp>
+      <p:sp>
+        <p:nvSpPr>
+          <p:cNvPr id="5" name="TextBox 4"/>
+          <p:cNvSpPr txBox="1"/>
+          <p:nvPr/>
+        </p:nvSpPr>
+        <p:spPr>
+          <a:xfrm>
+            <a:off x="310896" y="3273552"/>
+            <a:ext cx="1115568" cy="420624"/>
+          </a:xfrm>
+          <a:prstGeom prst="rect">
+            <a:avLst/>
+          </a:prstGeom>
+          <a:noFill/>
+        </p:spPr>
+        <p:txBody>
+          <a:bodyPr wrap="none" lIns="9144" rIns="9144" tIns="9144" bIns="9144">
+            <a:spAutoFit/>
+          </a:bodyPr>
+          <a:lstStyle/>
+          <a:p>
+            <a:pPr algn="ctr">
               <a:spcAft>
                 <a:spcPts val="100"/>
               </a:spcAft>
@@ -3635,21 +3684,57 @@
                 </a:solidFill>
                 <a:latin typeface="Arial"/>
               </a:rPr>
-              <a:t>× N</a:t>
-            </a:r>
-          </a:p>
-        </p:txBody>
-      </p:sp>
-      <p:sp>
-        <p:nvSpPr>
-          <p:cNvPr id="5" name="Rounded Rectangle 4"/>
+              <a:t>Mixture</a:t>
+            </a:r>
+          </a:p>
+        </p:txBody>
+      </p:sp>
+      <p:cxnSp>
+        <p:nvCxnSpPr>
+          <p:cNvPr id="6" name="Connector 5"/>
+          <p:cNvCxnSpPr/>
+          <p:nvPr/>
+        </p:nvCxnSpPr>
+        <p:spPr>
+          <a:xfrm>
+            <a:off x="1444752" y="3474720"/>
+            <a:ext cx="429767" cy="0"/>
+          </a:xfrm>
+          <a:prstGeom prst="line">
+            <a:avLst/>
+          </a:prstGeom>
+          <a:ln w="22860">
+            <a:solidFill>
+              <a:srgbClr val="44546A"/>
+            </a:solidFill>
+            <a:tailEnd type="triangle"/>
+          </a:ln>
+        </p:spPr>
+        <p:style>
+          <a:lnRef idx="2">
+            <a:schemeClr val="accent1"/>
+          </a:lnRef>
+          <a:fillRef idx="0">
+            <a:schemeClr val="accent1"/>
+          </a:fillRef>
+          <a:effectRef idx="0">
+            <a:schemeClr val="accent1"/>
+          </a:effectRef>
+          <a:fontRef idx="minor">
+            <a:schemeClr val="tx1"/>
+          </a:fontRef>
+        </p:style>
+      </p:cxnSp>
+      <p:sp>
+        <p:nvSpPr>
+          <p:cNvPr id="7" name="Rounded Rectangle 6"/>
           <p:cNvSpPr/>
           <p:nvPr/>
         </p:nvSpPr>
         <p:spPr>
           <a:xfrm>
-            <a:off x="1042415" y="2423160"/>
-            <a:ext cx="2350008" cy="777240"/>
+            <a:off x="1874519" y="2743200"/>
+            <a:ext cx="1472184" cy="1463040"/>
           </a:xfrm>
           <a:prstGeom prst="roundRect">
             <a:avLst>
@@ -3680,7 +3765,7 @@
           </a:fontRef>
         </p:style>
         <p:txBody>
-          <a:bodyPr rtlCol="0" anchor="ctr" wrap="none" lIns="27432" rIns="27432"/>
+          <a:bodyPr rtlCol="0" anchor="ctr" wrap="none" lIns="13716" rIns="13716"/>
           <a:lstStyle/>
           <a:p>
             <a:pPr algn="ctr">
@@ -3689,27 +3774,79 @@
               </a:spcAft>
             </a:pPr>
             <a:r>
-              <a:rPr sz="2300" b="1">
+              <a:rPr sz="2100" b="1">
                 <a:solidFill>
                   <a:srgbClr val="000000"/>
                 </a:solidFill>
                 <a:latin typeface="Arial"/>
               </a:rPr>
-              <a:t>Time Module</a:t>
-            </a:r>
-          </a:p>
-        </p:txBody>
-      </p:sp>
-      <p:sp>
-        <p:nvSpPr>
-          <p:cNvPr id="6" name="Rounded Rectangle 5"/>
+              <a:t>Time</a:t>
+            </a:r>
+          </a:p>
+          <a:p>
+            <a:pPr algn="ctr">
+              <a:spcAft>
+                <a:spcPts val="100"/>
+              </a:spcAft>
+            </a:pPr>
+            <a:r>
+              <a:rPr sz="2100" b="1">
+                <a:solidFill>
+                  <a:srgbClr val="000000"/>
+                </a:solidFill>
+                <a:latin typeface="Arial"/>
+              </a:rPr>
+              <a:t>Module</a:t>
+            </a:r>
+          </a:p>
+        </p:txBody>
+      </p:sp>
+      <p:cxnSp>
+        <p:nvCxnSpPr>
+          <p:cNvPr id="8" name="Connector 7"/>
+          <p:cNvCxnSpPr/>
+          <p:nvPr/>
+        </p:nvCxnSpPr>
+        <p:spPr>
+          <a:xfrm>
+            <a:off x="3346704" y="3474720"/>
+            <a:ext cx="310896" cy="0"/>
+          </a:xfrm>
+          <a:prstGeom prst="line">
+            <a:avLst/>
+          </a:prstGeom>
+          <a:ln w="22860">
+            <a:solidFill>
+              <a:srgbClr val="44546A"/>
+            </a:solidFill>
+            <a:tailEnd type="triangle"/>
+          </a:ln>
+        </p:spPr>
+        <p:style>
+          <a:lnRef idx="2">
+            <a:schemeClr val="accent1"/>
+          </a:lnRef>
+          <a:fillRef idx="0">
+            <a:schemeClr val="accent1"/>
+          </a:fillRef>
+          <a:effectRef idx="0">
+            <a:schemeClr val="accent1"/>
+          </a:effectRef>
+          <a:fontRef idx="minor">
+            <a:schemeClr val="tx1"/>
+          </a:fontRef>
+        </p:style>
+      </p:cxnSp>
+      <p:sp>
+        <p:nvSpPr>
+          <p:cNvPr id="9" name="Rounded Rectangle 8"/>
           <p:cNvSpPr/>
           <p:nvPr/>
         </p:nvSpPr>
         <p:spPr>
           <a:xfrm>
-            <a:off x="1042415" y="3639312"/>
-            <a:ext cx="2350008" cy="777240"/>
+            <a:off x="3657600" y="2743200"/>
+            <a:ext cx="1563624" cy="1463040"/>
           </a:xfrm>
           <a:prstGeom prst="roundRect">
             <a:avLst>
@@ -3740,7 +3877,7 @@
           </a:fontRef>
         </p:style>
         <p:txBody>
-          <a:bodyPr rtlCol="0" anchor="ctr" wrap="none" lIns="27432" rIns="27432"/>
+          <a:bodyPr rtlCol="0" anchor="ctr" wrap="none" lIns="13716" rIns="13716"/>
           <a:lstStyle/>
           <a:p>
             <a:pPr algn="ctr">
@@ -3749,7 +3886,7 @@
               </a:spcAft>
             </a:pPr>
             <a:r>
-              <a:rPr sz="2200" b="1">
+              <a:rPr sz="2100" b="1">
                 <a:solidFill>
                   <a:srgbClr val="000000"/>
                 </a:solidFill>
@@ -3765,7 +3902,7 @@
               </a:spcAft>
             </a:pPr>
             <a:r>
-              <a:rPr sz="2200" b="1">
+              <a:rPr sz="2100" b="1">
                 <a:solidFill>
                   <a:srgbClr val="000000"/>
                 </a:solidFill>
@@ -3778,14 +3915,14 @@
       </p:sp>
       <p:cxnSp>
         <p:nvCxnSpPr>
-          <p:cNvPr id="7" name="Connector 6"/>
+          <p:cNvPr id="10" name="Connector 9"/>
           <p:cNvCxnSpPr/>
           <p:nvPr/>
         </p:nvCxnSpPr>
         <p:spPr>
           <a:xfrm>
-            <a:off x="2217420" y="3200400"/>
-            <a:ext cx="0" cy="438912"/>
+            <a:off x="5221224" y="3474720"/>
+            <a:ext cx="841248" cy="0"/>
           </a:xfrm>
           <a:prstGeom prst="line">
             <a:avLst/>
@@ -3812,52 +3949,16 @@
           </a:fontRef>
         </p:style>
       </p:cxnSp>
-      <p:cxnSp>
-        <p:nvCxnSpPr>
-          <p:cNvPr id="8" name="Connector 7"/>
-          <p:cNvCxnSpPr/>
+      <p:sp>
+        <p:nvSpPr>
+          <p:cNvPr id="11" name="TextBox 10"/>
+          <p:cNvSpPr txBox="1"/>
           <p:nvPr/>
-        </p:nvCxnSpPr>
+        </p:nvSpPr>
         <p:spPr>
           <a:xfrm>
-            <a:off x="3392424" y="4027932"/>
-            <a:ext cx="1197864" cy="0"/>
-          </a:xfrm>
-          <a:prstGeom prst="line">
-            <a:avLst/>
-          </a:prstGeom>
-          <a:ln w="22860">
-            <a:solidFill>
-              <a:srgbClr val="44546A"/>
-            </a:solidFill>
-            <a:tailEnd type="triangle"/>
-          </a:ln>
-        </p:spPr>
-        <p:style>
-          <a:lnRef idx="2">
-            <a:schemeClr val="accent1"/>
-          </a:lnRef>
-          <a:fillRef idx="0">
-            <a:schemeClr val="accent1"/>
-          </a:fillRef>
-          <a:effectRef idx="0">
-            <a:schemeClr val="accent1"/>
-          </a:effectRef>
-          <a:fontRef idx="minor">
-            <a:schemeClr val="tx1"/>
-          </a:fontRef>
-        </p:style>
-      </p:cxnSp>
-      <p:sp>
-        <p:nvSpPr>
-          <p:cNvPr id="9" name="TextBox 8"/>
-          <p:cNvSpPr txBox="1"/>
-          <p:nvPr/>
-        </p:nvSpPr>
-        <p:spPr>
-          <a:xfrm>
-            <a:off x="3456432" y="3136392"/>
-            <a:ext cx="1143000" cy="347472"/>
+            <a:off x="5468112" y="2633472"/>
+            <a:ext cx="1243584" cy="329184"/>
           </a:xfrm>
           <a:prstGeom prst="rect">
             <a:avLst/>
@@ -3865,7 +3966,7 @@
           <a:noFill/>
         </p:spPr>
         <p:txBody>
-          <a:bodyPr wrap="none" lIns="18288" rIns="18288" tIns="9144" bIns="9144">
+          <a:bodyPr wrap="none" lIns="9144" rIns="9144" tIns="9144" bIns="9144">
             <a:spAutoFit/>
           </a:bodyPr>
           <a:lstStyle/>
@@ -3889,14 +3990,14 @@
       </p:sp>
       <p:sp>
         <p:nvSpPr>
-          <p:cNvPr id="10" name="Rounded Rectangle 9"/>
+          <p:cNvPr id="12" name="Rounded Rectangle 11"/>
           <p:cNvSpPr/>
           <p:nvPr/>
         </p:nvSpPr>
         <p:spPr>
           <a:xfrm>
-            <a:off x="4590288" y="3575304"/>
-            <a:ext cx="1664208" cy="905256"/>
+            <a:off x="6062472" y="2971800"/>
+            <a:ext cx="1307592" cy="1005840"/>
           </a:xfrm>
           <a:prstGeom prst="roundRect">
             <a:avLst>
@@ -3927,7 +4028,7 @@
           </a:fontRef>
         </p:style>
         <p:txBody>
-          <a:bodyPr rtlCol="0" anchor="ctr" wrap="none" lIns="27432" rIns="27432"/>
+          <a:bodyPr rtlCol="0" anchor="ctr" wrap="none" lIns="13716" rIns="13716"/>
           <a:lstStyle/>
           <a:p>
             <a:pPr algn="ctr">
@@ -3936,7 +4037,7 @@
               </a:spcAft>
             </a:pPr>
             <a:r>
-              <a:rPr sz="2300" b="1">
+              <a:rPr sz="2100" b="1">
                 <a:solidFill>
                   <a:srgbClr val="000000"/>
                 </a:solidFill>
@@ -3949,14 +4050,14 @@
       </p:sp>
       <p:cxnSp>
         <p:nvCxnSpPr>
-          <p:cNvPr id="11" name="Connector 10"/>
+          <p:cNvPr id="13" name="Connector 12"/>
           <p:cNvCxnSpPr/>
           <p:nvPr/>
         </p:nvCxnSpPr>
         <p:spPr>
           <a:xfrm>
-            <a:off x="6254496" y="4027932"/>
-            <a:ext cx="466344" cy="0"/>
+            <a:off x="7370064" y="3474720"/>
+            <a:ext cx="356615" cy="0"/>
           </a:xfrm>
           <a:prstGeom prst="line">
             <a:avLst/>
@@ -3984,14 +4085,14 @@
       </p:cxnSp>
       <p:cxnSp>
         <p:nvCxnSpPr>
-          <p:cNvPr id="12" name="Connector 11"/>
+          <p:cNvPr id="14" name="Connector 13"/>
           <p:cNvCxnSpPr/>
           <p:nvPr/>
         </p:nvCxnSpPr>
         <p:spPr>
           <a:xfrm>
-            <a:off x="6720840" y="2743200"/>
-            <a:ext cx="0" cy="2560320"/>
+            <a:off x="7726679" y="2377440"/>
+            <a:ext cx="0" cy="2194560"/>
           </a:xfrm>
           <a:prstGeom prst="line">
             <a:avLst/>
@@ -4019,14 +4120,14 @@
       </p:cxnSp>
       <p:cxnSp>
         <p:nvCxnSpPr>
-          <p:cNvPr id="13" name="Connector 12"/>
+          <p:cNvPr id="15" name="Connector 14"/>
           <p:cNvCxnSpPr/>
           <p:nvPr/>
         </p:nvCxnSpPr>
         <p:spPr>
           <a:xfrm>
-            <a:off x="6720840" y="2743200"/>
-            <a:ext cx="896112" cy="0"/>
+            <a:off x="7726679" y="2377440"/>
+            <a:ext cx="548641" cy="0"/>
           </a:xfrm>
           <a:prstGeom prst="line">
             <a:avLst/>
@@ -4055,14 +4156,14 @@
       </p:cxnSp>
       <p:sp>
         <p:nvSpPr>
-          <p:cNvPr id="14" name="TextBox 13"/>
+          <p:cNvPr id="16" name="TextBox 15"/>
           <p:cNvSpPr txBox="1"/>
           <p:nvPr/>
         </p:nvSpPr>
         <p:spPr>
           <a:xfrm>
-            <a:off x="6574536" y="2240280"/>
-            <a:ext cx="1051560" cy="329184"/>
+            <a:off x="8275320" y="1435608"/>
+            <a:ext cx="1801368" cy="301752"/>
           </a:xfrm>
           <a:prstGeom prst="rect">
             <a:avLst/>
@@ -4070,7 +4171,7 @@
           <a:noFill/>
         </p:spPr>
         <p:txBody>
-          <a:bodyPr wrap="none" lIns="18288" rIns="18288" tIns="9144" bIns="9144">
+          <a:bodyPr wrap="none" lIns="9144" rIns="9144" tIns="9144" bIns="9144">
             <a:spAutoFit/>
           </a:bodyPr>
           <a:lstStyle/>
@@ -4094,53 +4195,14 @@
       </p:sp>
       <p:sp>
         <p:nvSpPr>
-          <p:cNvPr id="15" name="TextBox 14"/>
-          <p:cNvSpPr txBox="1"/>
+          <p:cNvPr id="17" name="Rounded Rectangle 16"/>
+          <p:cNvSpPr/>
           <p:nvPr/>
         </p:nvSpPr>
         <p:spPr>
           <a:xfrm>
-            <a:off x="7616952" y="1801368"/>
-            <a:ext cx="2048256" cy="329184"/>
-          </a:xfrm>
-          <a:prstGeom prst="rect">
-            <a:avLst/>
-          </a:prstGeom>
-          <a:noFill/>
-        </p:spPr>
-        <p:txBody>
-          <a:bodyPr wrap="none" lIns="18288" rIns="18288" tIns="9144" bIns="9144">
-            <a:spAutoFit/>
-          </a:bodyPr>
-          <a:lstStyle/>
-          <a:p>
-            <a:pPr algn="ctr">
-              <a:spcAft>
-                <a:spcPts val="100"/>
-              </a:spcAft>
-            </a:pPr>
-            <a:r>
-              <a:rPr sz="1800" b="0">
-                <a:solidFill>
-                  <a:srgbClr val="777777"/>
-                </a:solidFill>
-                <a:latin typeface="Arial"/>
-              </a:rPr>
-              <a:t>Speaker 1</a:t>
-            </a:r>
-          </a:p>
-        </p:txBody>
-      </p:sp>
-      <p:sp>
-        <p:nvSpPr>
-          <p:cNvPr id="16" name="Rounded Rectangle 15"/>
-          <p:cNvSpPr/>
-          <p:nvPr/>
-        </p:nvSpPr>
-        <p:spPr>
-          <a:xfrm>
-            <a:off x="7616952" y="2286000"/>
-            <a:ext cx="2048256" cy="914400"/>
+            <a:off x="8275320" y="1828800"/>
+            <a:ext cx="1801368" cy="1097280"/>
           </a:xfrm>
           <a:prstGeom prst="roundRect">
             <a:avLst>
@@ -4171,7 +4233,7 @@
           </a:fontRef>
         </p:style>
         <p:txBody>
-          <a:bodyPr rtlCol="0" anchor="ctr" wrap="none" lIns="27432" rIns="27432"/>
+          <a:bodyPr rtlCol="0" anchor="ctr" wrap="none" lIns="13716" rIns="13716"/>
           <a:lstStyle/>
           <a:p>
             <a:pPr algn="ctr">
@@ -4180,7 +4242,7 @@
               </a:spcAft>
             </a:pPr>
             <a:r>
-              <a:rPr sz="2200" b="1">
+              <a:rPr sz="2100" b="1">
                 <a:solidFill>
                   <a:srgbClr val="000000"/>
                 </a:solidFill>
@@ -4196,7 +4258,7 @@
               </a:spcAft>
             </a:pPr>
             <a:r>
-              <a:rPr sz="2200" b="1">
+              <a:rPr sz="2100" b="1">
                 <a:solidFill>
                   <a:srgbClr val="000000"/>
                 </a:solidFill>
@@ -4209,13 +4271,13 @@
       </p:sp>
       <p:cxnSp>
         <p:nvCxnSpPr>
-          <p:cNvPr id="17" name="Connector 16"/>
+          <p:cNvPr id="18" name="Connector 17"/>
           <p:cNvCxnSpPr/>
           <p:nvPr/>
         </p:nvCxnSpPr>
         <p:spPr>
           <a:xfrm>
-            <a:off x="9665208" y="2743200"/>
+            <a:off x="10076688" y="2377440"/>
             <a:ext cx="484632" cy="0"/>
           </a:xfrm>
           <a:prstGeom prst="line">
@@ -4245,14 +4307,14 @@
       </p:cxnSp>
       <p:sp>
         <p:nvSpPr>
-          <p:cNvPr id="18" name="TextBox 17"/>
+          <p:cNvPr id="19" name="TextBox 18"/>
           <p:cNvSpPr txBox="1"/>
           <p:nvPr/>
         </p:nvSpPr>
         <p:spPr>
           <a:xfrm>
-            <a:off x="10314432" y="2496312"/>
-            <a:ext cx="1444752" cy="438912"/>
+            <a:off x="10643616" y="2157984"/>
+            <a:ext cx="1161288" cy="429768"/>
           </a:xfrm>
           <a:prstGeom prst="rect">
             <a:avLst/>
@@ -4260,18 +4322,18 @@
           <a:noFill/>
         </p:spPr>
         <p:txBody>
-          <a:bodyPr wrap="none" lIns="18288" rIns="18288" tIns="9144" bIns="9144">
+          <a:bodyPr wrap="none" lIns="9144" rIns="9144" tIns="9144" bIns="9144">
             <a:spAutoFit/>
           </a:bodyPr>
           <a:lstStyle/>
           <a:p>
-            <a:pPr algn="l">
+            <a:pPr algn="ctr">
               <a:spcAft>
                 <a:spcPts val="100"/>
               </a:spcAft>
             </a:pPr>
             <a:r>
-              <a:rPr sz="2600" b="1">
+              <a:rPr sz="2400" b="1">
                 <a:solidFill>
                   <a:srgbClr val="000000"/>
                 </a:solidFill>
@@ -4284,14 +4346,14 @@
       </p:sp>
       <p:cxnSp>
         <p:nvCxnSpPr>
-          <p:cNvPr id="19" name="Connector 18"/>
+          <p:cNvPr id="20" name="Connector 19"/>
           <p:cNvCxnSpPr/>
           <p:nvPr/>
         </p:nvCxnSpPr>
         <p:spPr>
           <a:xfrm>
-            <a:off x="6720840" y="5303520"/>
-            <a:ext cx="896112" cy="0"/>
+            <a:off x="7726679" y="4572000"/>
+            <a:ext cx="548641" cy="0"/>
           </a:xfrm>
           <a:prstGeom prst="line">
             <a:avLst/>
@@ -4320,14 +4382,14 @@
       </p:cxnSp>
       <p:sp>
         <p:nvSpPr>
-          <p:cNvPr id="20" name="TextBox 19"/>
+          <p:cNvPr id="21" name="TextBox 20"/>
           <p:cNvSpPr txBox="1"/>
           <p:nvPr/>
         </p:nvSpPr>
         <p:spPr>
           <a:xfrm>
-            <a:off x="6574536" y="4800600"/>
-            <a:ext cx="1051560" cy="329184"/>
+            <a:off x="8275320" y="3630168"/>
+            <a:ext cx="1801368" cy="301752"/>
           </a:xfrm>
           <a:prstGeom prst="rect">
             <a:avLst/>
@@ -4335,7 +4397,7 @@
           <a:noFill/>
         </p:spPr>
         <p:txBody>
-          <a:bodyPr wrap="none" lIns="18288" rIns="18288" tIns="9144" bIns="9144">
+          <a:bodyPr wrap="none" lIns="9144" rIns="9144" tIns="9144" bIns="9144">
             <a:spAutoFit/>
           </a:bodyPr>
           <a:lstStyle/>
@@ -4359,53 +4421,14 @@
       </p:sp>
       <p:sp>
         <p:nvSpPr>
-          <p:cNvPr id="21" name="TextBox 20"/>
-          <p:cNvSpPr txBox="1"/>
-          <p:nvPr/>
-        </p:nvSpPr>
-        <p:spPr>
-          <a:xfrm>
-            <a:off x="7616952" y="4361688"/>
-            <a:ext cx="2048256" cy="329184"/>
-          </a:xfrm>
-          <a:prstGeom prst="rect">
-            <a:avLst/>
-          </a:prstGeom>
-          <a:noFill/>
-        </p:spPr>
-        <p:txBody>
-          <a:bodyPr wrap="none" lIns="18288" rIns="18288" tIns="9144" bIns="9144">
-            <a:spAutoFit/>
-          </a:bodyPr>
-          <a:lstStyle/>
-          <a:p>
-            <a:pPr algn="ctr">
-              <a:spcAft>
-                <a:spcPts val="100"/>
-              </a:spcAft>
-            </a:pPr>
-            <a:r>
-              <a:rPr sz="1800" b="0">
-                <a:solidFill>
-                  <a:srgbClr val="777777"/>
-                </a:solidFill>
-                <a:latin typeface="Arial"/>
-              </a:rPr>
-              <a:t>Speaker 2</a:t>
-            </a:r>
-          </a:p>
-        </p:txBody>
-      </p:sp>
-      <p:sp>
-        <p:nvSpPr>
           <p:cNvPr id="22" name="Rounded Rectangle 21"/>
           <p:cNvSpPr/>
           <p:nvPr/>
         </p:nvSpPr>
         <p:spPr>
           <a:xfrm>
-            <a:off x="7616952" y="4846320"/>
-            <a:ext cx="2048256" cy="914400"/>
+            <a:off x="8275320" y="4023360"/>
+            <a:ext cx="1801368" cy="1097280"/>
           </a:xfrm>
           <a:prstGeom prst="roundRect">
             <a:avLst>
@@ -4436,7 +4459,7 @@
           </a:fontRef>
         </p:style>
         <p:txBody>
-          <a:bodyPr rtlCol="0" anchor="ctr" wrap="none" lIns="27432" rIns="27432"/>
+          <a:bodyPr rtlCol="0" anchor="ctr" wrap="none" lIns="13716" rIns="13716"/>
           <a:lstStyle/>
           <a:p>
             <a:pPr algn="ctr">
@@ -4445,7 +4468,7 @@
               </a:spcAft>
             </a:pPr>
             <a:r>
-              <a:rPr sz="2200" b="1">
+              <a:rPr sz="2100" b="1">
                 <a:solidFill>
                   <a:srgbClr val="000000"/>
                 </a:solidFill>
@@ -4461,7 +4484,7 @@
               </a:spcAft>
             </a:pPr>
             <a:r>
-              <a:rPr sz="2200" b="1">
+              <a:rPr sz="2100" b="1">
                 <a:solidFill>
                   <a:srgbClr val="000000"/>
                 </a:solidFill>
@@ -4480,7 +4503,7 @@
         </p:nvCxnSpPr>
         <p:spPr>
           <a:xfrm>
-            <a:off x="9665208" y="5303520"/>
+            <a:off x="10076688" y="4572000"/>
             <a:ext cx="484632" cy="0"/>
           </a:xfrm>
           <a:prstGeom prst="line">
@@ -4516,8 +4539,8 @@
         </p:nvSpPr>
         <p:spPr>
           <a:xfrm>
-            <a:off x="10314432" y="5056631"/>
-            <a:ext cx="1444752" cy="438912"/>
+            <a:off x="10643616" y="4352544"/>
+            <a:ext cx="1161288" cy="429768"/>
           </a:xfrm>
           <a:prstGeom prst="rect">
             <a:avLst/>
@@ -4525,18 +4548,18 @@
           <a:noFill/>
         </p:spPr>
         <p:txBody>
-          <a:bodyPr wrap="none" lIns="18288" rIns="18288" tIns="9144" bIns="9144">
+          <a:bodyPr wrap="none" lIns="9144" rIns="9144" tIns="9144" bIns="9144">
             <a:spAutoFit/>
           </a:bodyPr>
           <a:lstStyle/>
           <a:p>
-            <a:pPr algn="l">
+            <a:pPr algn="ctr">
               <a:spcAft>
                 <a:spcPts val="100"/>
               </a:spcAft>
             </a:pPr>
             <a:r>
-              <a:rPr sz="2600" b="1">
+              <a:rPr sz="2400" b="1">
                 <a:solidFill>
                   <a:srgbClr val="000000"/>
                 </a:solidFill>
@@ -4564,7 +4587,7 @@
           <a:noFill/>
         </p:spPr>
         <p:txBody>
-          <a:bodyPr wrap="none" lIns="18288" rIns="18288" tIns="9144" bIns="9144">
+          <a:bodyPr wrap="none" lIns="9144" rIns="9144" tIns="9144" bIns="9144">
             <a:spAutoFit/>
           </a:bodyPr>
           <a:lstStyle/>

</xml_diff>